<commit_message>
Align LoRA memory figures with what Render measured (490→283MB)
Home stat, project stat and story text said ~240MB, which was a local
Windows measurement. Also refreshes the downloadable study deck.

Co-Authored-By: Claude Sonnet 5.5 <noreply@anthropic.com>
</commit_message>
<xml_diff>
--- a/public/downloads/seis-proyectos-de-ia.pptx
+++ b/public/downloads/seis-proyectos-de-ia.pptx
@@ -38683,7 +38683,7 @@
                 <a:ea typeface="Calibri" pitchFamily="34" charset="-122"/>
                 <a:cs typeface="Calibri" pitchFamily="34" charset="-120"/>
               </a:rPr>
-              <a:t>se eliminó torch/transformers/optimum del todo: onnxruntime + loop de decodificación manual -- de ~490MB a ~240MB en reposo, estable</a:t>
+              <a:t>se eliminó torch/transformers/optimum del todo: onnxruntime + loop de decodificación manual -- de ~490MB a ~283MB al iniciar, estable</a:t>
             </a:r>
             <a:endParaRPr lang="en-US" sz="1250" dirty="0"/>
           </a:p>
@@ -39410,7 +39410,7 @@
                 <a:ea typeface="Calibri" pitchFamily="34" charset="-122"/>
                 <a:cs typeface="Calibri" pitchFamily="34" charset="-120"/>
               </a:rPr>
-              <a:t>✓ Verificado en producción tras 4 intentos: ~240MB en reposo, ~345MB estable bajo solicitudes reales repetidas -- 6 de 6 generaciones correctas, cero caídas por memoria.</a:t>
+              <a:t>✓ Verificado en producción tras 4 intentos: ~283MB al iniciar, ~345MB estable bajo solicitudes reales repetidas -- 6 de 6 generaciones correctas, cero caídas por memoria.</a:t>
             </a:r>
             <a:endParaRPr lang="en-US" sz="1400" dirty="0"/>
           </a:p>

</xml_diff>